<commit_message>
Propagate the diffusion envelopes into both shipped docs and the deck
The package claimed 93.6-96.0 for Ch2 and nothing about diffusion for Ch1, while
91.2-96.0 and 94.0-96.0 were already measured and on disk. Shipping the narrower
numbers would be a claim the deliverable's own data no longer supports -- the
error class this whole audit has been about.

Ch1 doc now carries the diffusion table and the finding that ipSAE is stable
(0.039) while DockQ is not (0.109, crossing a band edge on 2 of 5) -- and that we
predicted the opposite in advance and were wrong.

Ch2 doc now carries its diffusion table, that three of five samples fall to
Medium, that the lowest sample (0.736) is still well clear of the 0.60 cutoff so
viability holds, and that model_0 is the argmax by construction.

Deck slide 3 gains the second axis.

VALIDATION PASSED, both challenges, from the packaged files alone.

Co-Authored-By: Claude Opus 5 (1M context) <noreply@anthropic.com>
</commit_message>
<xml_diff>
--- a/submission/LOCKSMITH_DEV/pitch/LOCKSMITH_DEV_presentation.pptx
+++ b/submission/LOCKSMITH_DEV/pitch/LOCKSMITH_DEV_presentation.pptx
@@ -3849,7 +3849,7 @@
               </a:defRPr>
             </a:pPr>
             <a:r>
-              <a:t>Range across depth</a:t>
+              <a:t>ipSAE range across recycling depth</a:t>
             </a:r>
           </a:p>
           <a:p>
@@ -3956,15 +3956,57 @@
               <a:spcAft>
                 <a:spcPts val="700"/>
               </a:spcAft>
+              <a:defRPr sz="1400" b="1">
+                <a:solidFill>
+                  <a:srgbClr val="1A1A1A"/>
+                </a:solidFill>
+              </a:defRPr>
+            </a:pPr>
+            <a:r>
+              <a:t>A second axis, same story:</a:t>
+            </a:r>
+          </a:p>
+          <a:p>
+            <a:pPr lvl="1">
+              <a:spcAft>
+                <a:spcPts val="700"/>
+              </a:spcAft>
+              <a:defRPr sz="1200" b="0">
+                <a:solidFill>
+                  <a:srgbClr val="606060"/>
+                </a:solidFill>
+              </a:defRPr>
+            </a:pPr>
+            <a:r>
+              <a:t>Boltz returns its models RANKED. With diffusion_samples=1 you get the argmax, not a sample. Asking for five costs 2m54s vs 2m.</a:t>
+            </a:r>
+          </a:p>
+          <a:p>
+            <a:pPr lvl="1">
+              <a:spcAft>
+                <a:spcPts val="700"/>
+              </a:spcAft>
+              <a:defRPr sz="1200" b="1">
+                <a:solidFill>
+                  <a:srgbClr val="B03020"/>
+                </a:solidFill>
+              </a:defRPr>
+            </a:pPr>
+            <a:r>
+              <a:t>Ch1 94.0–96.0 · Ch2 91.2–96.0</a:t>
+            </a:r>
+          </a:p>
+          <a:p>
+            <a:pPr>
+              <a:spcAft>
+                <a:spcPts val="700"/>
+              </a:spcAft>
               <a:defRPr sz="1400" b="0">
                 <a:solidFill>
-                  <a:srgbClr val="606060"/>
-                </a:solidFill>
-              </a:defRPr>
-            </a:pPr>
-            <a:r>
-              <a:t>So our own headline is 93.6–96.0 depending on depth and seed, and we report it that way.</a:t>
-            </a:r>
+                  <a:srgbClr val="1A1A1A"/>
+                </a:solidFill>
+              </a:defRPr>
+            </a:pPr>
           </a:p>
           <a:p>
             <a:pPr>
@@ -3978,7 +4020,7 @@
               </a:defRPr>
             </a:pPr>
             <a:r>
-              <a:t>The variance is a better result than the score.</a:t>
+              <a:t>Every pose-derived number we have ever reported sat at the top of a distribution we never sampled.</a:t>
             </a:r>
           </a:p>
         </p:txBody>

</xml_diff>